<commit_message>
Add project framework slide detailing methodology, goals, I/O, and risk mitigation using Low/Medium/High metrics
</commit_message>
<xml_diff>
--- a/project_reports/Capstone_Proposal_RiveraruizJose.pptx
+++ b/project_reports/Capstone_Proposal_RiveraruizJose.pptx
@@ -26929,7 +26929,7 @@
                 <a:latin typeface="Arial" panose="020B0604020202020204" pitchFamily="34" charset="0"/>
                 <a:cs typeface="Arial" panose="020B0604020202020204" pitchFamily="34" charset="0"/>
               </a:rPr>
-              <a:t>(capturing “shock</a:t>
+              <a:t>(capturing “shock </a:t>
             </a:r>
           </a:p>
           <a:p>
@@ -26938,7 +26938,7 @@
                 <a:latin typeface="Arial" panose="020B0604020202020204" pitchFamily="34" charset="0"/>
                 <a:cs typeface="Arial" panose="020B0604020202020204" pitchFamily="34" charset="0"/>
               </a:rPr>
-              <a:t>Cliffs”)</a:t>
+              <a:t>  cliffs”)</a:t>
             </a:r>
           </a:p>
         </p:txBody>
@@ -27188,7 +27188,7 @@
         </p:nvSpPr>
         <p:spPr>
           <a:xfrm>
-            <a:off x="8707721" y="3977385"/>
+            <a:off x="8707721" y="3926583"/>
             <a:ext cx="1683474" cy="1569660"/>
           </a:xfrm>
           <a:prstGeom prst="rect">

</xml_diff>

<commit_message>
Add crude birth and death rates information
</commit_message>
<xml_diff>
--- a/project_reports/Capstone_Proposal_RiveraruizJose.pptx
+++ b/project_reports/Capstone_Proposal_RiveraruizJose.pptx
@@ -24514,8 +24514,8 @@
           </a:p>
         </p:txBody>
       </p:sp>
-      <mc:AlternateContent xmlns:mc="http://schemas.openxmlformats.org/markup-compatibility/2006">
-        <mc:Choice xmlns:a14="http://schemas.microsoft.com/office/drawing/2010/main" Requires="a14">
+      <mc:AlternateContent xmlns:mc="http://schemas.openxmlformats.org/markup-compatibility/2006" xmlns:a14="http://schemas.microsoft.com/office/drawing/2010/main">
+        <mc:Choice Requires="a14">
           <p:graphicFrame>
             <p:nvGraphicFramePr>
               <p:cNvPr id="3" name="Table 2">
@@ -25079,7 +25079,7 @@
             </a:graphic>
           </p:graphicFrame>
         </mc:Choice>
-        <mc:Fallback>
+        <mc:Fallback xmlns="">
           <p:graphicFrame>
             <p:nvGraphicFramePr>
               <p:cNvPr id="3" name="Table 2">
@@ -26209,8 +26209,8 @@
           </a:p>
         </p:txBody>
       </p:sp>
-      <mc:AlternateContent xmlns:mc="http://schemas.openxmlformats.org/markup-compatibility/2006">
-        <mc:Choice xmlns:a14="http://schemas.microsoft.com/office/drawing/2010/main" Requires="a14">
+      <mc:AlternateContent xmlns:mc="http://schemas.openxmlformats.org/markup-compatibility/2006" xmlns:a14="http://schemas.microsoft.com/office/drawing/2010/main">
+        <mc:Choice Requires="a14">
           <p:sp>
             <p:nvSpPr>
               <p:cNvPr id="19" name="TextBox 18">
@@ -26318,7 +26318,7 @@
             </p:txBody>
           </p:sp>
         </mc:Choice>
-        <mc:Fallback>
+        <mc:Fallback xmlns="">
           <p:sp>
             <p:nvSpPr>
               <p:cNvPr id="19" name="TextBox 18">
@@ -26401,8 +26401,8 @@
           </a:p>
         </p:txBody>
       </p:sp>
-      <mc:AlternateContent xmlns:mc="http://schemas.openxmlformats.org/markup-compatibility/2006">
-        <mc:Choice xmlns:a14="http://schemas.microsoft.com/office/drawing/2010/main" Requires="a14">
+      <mc:AlternateContent xmlns:mc="http://schemas.openxmlformats.org/markup-compatibility/2006" xmlns:a14="http://schemas.microsoft.com/office/drawing/2010/main">
+        <mc:Choice Requires="a14">
           <p:sp>
             <p:nvSpPr>
               <p:cNvPr id="21" name="TextBox 20">
@@ -26496,7 +26496,7 @@
             </p:txBody>
           </p:sp>
         </mc:Choice>
-        <mc:Fallback>
+        <mc:Fallback xmlns="">
           <p:sp>
             <p:nvSpPr>
               <p:cNvPr id="21" name="TextBox 20">

</xml_diff>